<commit_message>
Final velocity Monte Carlo (100,000 trials) and final deck
- mc_velocity_summary.json from the full run: SD 0.50 m/s, 95 % +/-0.98,
  99 % +/-1.29 m/s; convergence, 5 seeds and 9 sensitivity cases
- fix: "half of drift is GPS's" sensitivity passed the relative drift SD to
  the additive model; rerun with sd_slow_abs/sqrt(2) -> 95 % +/-0.70 m/s
- 07_mc_velocity.py --replot redraws figures/mc_vel.png from saved results
- deck: DRAFT label removed, bias row and dominant-assumption note on the
  validation slide; final_metrics.json and briefing regenerated

Co-Authored-By: Claude Opus 5.5 <noreply@anthropic.com>
</commit_message>
<xml_diff>
--- a/analysis/out/GroundSpeed_Forensics.pptx
+++ b/analysis/out/GroundSpeed_Forensics.pptx
@@ -4288,48 +4288,6 @@
           </a:p>
         </p:txBody>
       </p:sp>
-      <p:sp>
-        <p:nvSpPr>
-          <p:cNvPr id="8" name="TextBox 7"/>
-          <p:cNvSpPr txBox="1"/>
-          <p:nvPr/>
-        </p:nvSpPr>
-        <p:spPr>
-          <a:xfrm>
-            <a:off x="914400" y="6172200"/>
-            <a:ext cx="10515600" cy="365760"/>
-          </a:xfrm>
-          <a:prstGeom prst="rect">
-            <a:avLst/>
-          </a:prstGeom>
-          <a:noFill/>
-        </p:spPr>
-        <p:txBody>
-          <a:bodyPr wrap="square" anchor="t" lIns="36576" rIns="36576" tIns="18288" bIns="18288">
-            <a:spAutoFit/>
-          </a:bodyPr>
-          <a:lstStyle/>
-          <a:p>
-            <a:pPr algn="l">
-              <a:lnSpc>
-                <a:spcPct val="105000"/>
-              </a:lnSpc>
-              <a:spcAft>
-                <a:spcPts val="400"/>
-              </a:spcAft>
-            </a:pPr>
-            <a:r>
-              <a:rPr sz="1200" b="1">
-                <a:solidFill>
-                  <a:srgbClr val="E69F00"/>
-                </a:solidFill>
-                <a:latin typeface="Calibri"/>
-              </a:rPr>
-              <a:t>DRAFT: velocity Monte Carlo shown from 5,000 trials; its sensitivity and convergence checks are still running.</a:t>
-            </a:r>
-          </a:p>
-        </p:txBody>
-      </p:sp>
     </p:spTree>
   </p:cSld>
   <p:clrMapOvr>
@@ -8850,7 +8808,7 @@
                           </a:solidFill>
                           <a:latin typeface="Calibri"/>
                         </a:rPr>
-                        <a:t>100,000 distance · 5,000 velocity</a:t>
+                        <a:t>100,000 distance · 100,000 velocity</a:t>
                       </a:r>
                     </a:p>
                   </a:txBody>
@@ -9230,8 +9188,8 @@
         </p:blipFill>
         <p:spPr>
           <a:xfrm>
-            <a:off x="320040" y="3806189"/>
-            <a:ext cx="5943600" cy="2080260"/>
+            <a:off x="320040" y="3954779"/>
+            <a:ext cx="5943599" cy="1783079"/>
           </a:xfrm>
           <a:prstGeom prst="rect">
             <a:avLst/>
@@ -9867,7 +9825,7 @@
                           </a:solidFill>
                           <a:latin typeface="Calibri"/>
                         </a:rPr>
-                        <a:t>+0.00 / 0.50 m/s</a:t>
+                        <a:t>−0.00 / 0.50 m/s</a:t>
                       </a:r>
                     </a:p>
                   </a:txBody>
@@ -10003,7 +9961,7 @@
                           </a:solidFill>
                           <a:latin typeface="Calibri"/>
                         </a:rPr>
-                        <a:t>−1.30…1.29 m/s</a:t>
+                        <a:t>−1.29…1.29 m/s</a:t>
                       </a:r>
                     </a:p>
                   </a:txBody>
@@ -10025,7 +9983,7 @@
                           </a:solidFill>
                           <a:latin typeface="Calibri"/>
                         </a:rPr>
-                        <a:t>|e|₉₉ 0.83 m/s</a:t>
+                        <a:t>|e|₉₉ 0.82 m/s</a:t>
                       </a:r>
                     </a:p>
                   </a:txBody>
@@ -10414,7 +10372,7 @@
         </p:nvGraphicFramePr>
         <p:xfrm>
           <a:off x="4389120" y="1371600"/>
-          <a:ext cx="7452360" cy="1920240"/>
+          <a:ext cx="7452360" cy="2194560"/>
         </p:xfrm>
         <a:graphic>
           <a:graphicData uri="http://schemas.openxmlformats.org/drawingml/2006/table">
@@ -10427,7 +10385,7 @@
                 <a:gridCol w="2880360"/>
                 <a:gridCol w="2926080"/>
               </a:tblGrid>
-              <a:tr h="384048">
+              <a:tr h="365760">
                 <a:tc>
                   <a:txBody>
                     <a:bodyPr/>
@@ -10495,7 +10453,7 @@
                   </a:tcPr>
                 </a:tc>
               </a:tr>
-              <a:tr h="384048">
+              <a:tr h="365760">
                 <a:tc>
                   <a:txBody>
                     <a:bodyPr/>
@@ -10508,12 +10466,148 @@
                           </a:solidFill>
                           <a:latin typeface="Calibri"/>
                         </a:rPr>
+                        <a:t>Mean (bias)</a:t>
+                      </a:r>
+                    </a:p>
+                  </a:txBody>
+                  <a:tcPr marL="54864" marR="54864" marT="18288" marB="18288">
+                    <a:solidFill>
+                      <a:srgbClr val="F2F5F8"/>
+                    </a:solidFill>
+                  </a:tcPr>
+                </a:tc>
+                <a:tc>
+                  <a:txBody>
+                    <a:bodyPr/>
+                    <a:lstStyle/>
+                    <a:p>
+                      <a:r>
+                        <a:rPr sz="1050" b="0">
+                          <a:solidFill>
+                            <a:srgbClr val="1F232B"/>
+                          </a:solidFill>
+                          <a:latin typeface="Calibri"/>
+                        </a:rPr>
+                        <a:t>LOO mean +0.00 % vs MC +0.00 %</a:t>
+                      </a:r>
+                    </a:p>
+                  </a:txBody>
+                  <a:tcPr marL="54864" marR="54864" marT="18288" marB="18288">
+                    <a:solidFill>
+                      <a:srgbClr val="F2F5F8"/>
+                    </a:solidFill>
+                  </a:tcPr>
+                </a:tc>
+                <a:tc>
+                  <a:txBody>
+                    <a:bodyPr/>
+                    <a:lstStyle/>
+                    <a:p>
+                      <a:r>
+                        <a:rPr sz="1050" b="0">
+                          <a:solidFill>
+                            <a:srgbClr val="1F232B"/>
+                          </a:solidFill>
+                          <a:latin typeface="Calibri"/>
+                        </a:rPr>
+                        <a:t>real +0.19 vs MC −0.00 m/s (real 95 % CI −0.09…0.41; drift model is zero-mean)</a:t>
+                      </a:r>
+                    </a:p>
+                  </a:txBody>
+                  <a:tcPr marL="54864" marR="54864" marT="18288" marB="18288">
+                    <a:solidFill>
+                      <a:srgbClr val="F2F5F8"/>
+                    </a:solidFill>
+                  </a:tcPr>
+                </a:tc>
+              </a:tr>
+              <a:tr h="365760">
+                <a:tc>
+                  <a:txBody>
+                    <a:bodyPr/>
+                    <a:lstStyle/>
+                    <a:p>
+                      <a:r>
+                        <a:rPr sz="1050" b="0">
+                          <a:solidFill>
+                            <a:srgbClr val="1F232B"/>
+                          </a:solidFill>
+                          <a:latin typeface="Calibri"/>
+                        </a:rPr>
                         <a:t>Real vs MC spread</a:t>
                       </a:r>
                     </a:p>
                   </a:txBody>
                   <a:tcPr marL="54864" marR="54864" marT="18288" marB="18288">
                     <a:solidFill>
+                      <a:srgbClr val="FFFFFF"/>
+                    </a:solidFill>
+                  </a:tcPr>
+                </a:tc>
+                <a:tc>
+                  <a:txBody>
+                    <a:bodyPr/>
+                    <a:lstStyle/>
+                    <a:p>
+                      <a:r>
+                        <a:rPr sz="1050" b="0">
+                          <a:solidFill>
+                            <a:srgbClr val="1F232B"/>
+                          </a:solidFill>
+                          <a:latin typeface="Calibri"/>
+                        </a:rPr>
+                        <a:t>LOO SD 0.44 % vs MC 0.44 %</a:t>
+                      </a:r>
+                    </a:p>
+                  </a:txBody>
+                  <a:tcPr marL="54864" marR="54864" marT="18288" marB="18288">
+                    <a:solidFill>
+                      <a:srgbClr val="FFFFFF"/>
+                    </a:solidFill>
+                  </a:tcPr>
+                </a:tc>
+                <a:tc>
+                  <a:txBody>
+                    <a:bodyPr/>
+                    <a:lstStyle/>
+                    <a:p>
+                      <a:r>
+                        <a:rPr sz="1050" b="0">
+                          <a:solidFill>
+                            <a:srgbClr val="1F232B"/>
+                          </a:solidFill>
+                          <a:latin typeface="Calibri"/>
+                        </a:rPr>
+                        <a:t>real SD 0.50 vs MC (incl. GPS noise) 0.53 m/s</a:t>
+                      </a:r>
+                    </a:p>
+                  </a:txBody>
+                  <a:tcPr marL="54864" marR="54864" marT="18288" marB="18288">
+                    <a:solidFill>
+                      <a:srgbClr val="FFFFFF"/>
+                    </a:solidFill>
+                  </a:tcPr>
+                </a:tc>
+              </a:tr>
+              <a:tr h="365760">
+                <a:tc>
+                  <a:txBody>
+                    <a:bodyPr/>
+                    <a:lstStyle/>
+                    <a:p>
+                      <a:r>
+                        <a:rPr sz="1050" b="0">
+                          <a:solidFill>
+                            <a:srgbClr val="1F232B"/>
+                          </a:solidFill>
+                          <a:latin typeface="Calibri"/>
+                        </a:rPr>
+                        <a:t>Tails</a:t>
+                      </a:r>
+                    </a:p>
+                  </a:txBody>
+                  <a:tcPr marL="54864" marR="54864" marT="18288" marB="18288">
+                    <a:solidFill>
                       <a:srgbClr val="F2F5F8"/>
                     </a:solidFill>
                   </a:tcPr>
@@ -10530,7 +10624,7 @@
                           </a:solidFill>
                           <a:latin typeface="Calibri"/>
                         </a:rPr>
-                        <a:t>LOO SD 0.44 % vs MC 0.44 %</a:t>
+                        <a:t>worst real LOO run at MC pct 79</a:t>
                       </a:r>
                     </a:p>
                   </a:txBody>
@@ -10552,7 +10646,7 @@
                           </a:solidFill>
                           <a:latin typeface="Calibri"/>
                         </a:rPr>
-                        <a:t>real SD 0.50 vs MC (incl. GPS noise) 0.52 m/s</a:t>
+                        <a:t>|e|₉₅ real 1.01 vs MC 1.03 m/s</a:t>
                       </a:r>
                     </a:p>
                   </a:txBody>
@@ -10563,7 +10657,7 @@
                   </a:tcPr>
                 </a:tc>
               </a:tr>
-              <a:tr h="384048">
+              <a:tr h="365760">
                 <a:tc>
                   <a:txBody>
                     <a:bodyPr/>
@@ -10576,7 +10670,7 @@
                           </a:solidFill>
                           <a:latin typeface="Calibri"/>
                         </a:rPr>
-                        <a:t>Tails</a:t>
+                        <a:t>Analytic</a:t>
                       </a:r>
                     </a:p>
                   </a:txBody>
@@ -10598,7 +10692,7 @@
                           </a:solidFill>
                           <a:latin typeface="Calibri"/>
                         </a:rPr>
-                        <a:t>worst real LOO run at MC pct 79</a:t>
+                        <a:t>independent-term SD 0.43 % vs MC 0.44 %</a:t>
                       </a:r>
                     </a:p>
                   </a:txBody>
@@ -10620,7 +10714,7 @@
                           </a:solidFill>
                           <a:latin typeface="Calibri"/>
                         </a:rPr>
-                        <a:t>|e|₉₅ real 1.01 vs MC 1.03 m/s</a:t>
+                        <a:t>filter's own σ (white noise only) 12 mm/s ≪ real error</a:t>
                       </a:r>
                     </a:p>
                   </a:txBody>
@@ -10631,7 +10725,7 @@
                   </a:tcPr>
                 </a:tc>
               </a:tr>
-              <a:tr h="384048">
+              <a:tr h="365760">
                 <a:tc>
                   <a:txBody>
                     <a:bodyPr/>
@@ -10644,7 +10738,7 @@
                           </a:solidFill>
                           <a:latin typeface="Calibri"/>
                         </a:rPr>
-                        <a:t>Analytic</a:t>
+                        <a:t>Convergence / seeds</a:t>
                       </a:r>
                     </a:p>
                   </a:txBody>
@@ -10666,7 +10760,7 @@
                           </a:solidFill>
                           <a:latin typeface="Calibri"/>
                         </a:rPr>
-                        <a:t>independent-term SD 0.43 % vs MC 0.44 %</a:t>
+                        <a:t>|e|₉₉ within ±0.01 % across 5 seeds</a:t>
                       </a:r>
                     </a:p>
                   </a:txBody>
@@ -10688,81 +10782,13 @@
                           </a:solidFill>
                           <a:latin typeface="Calibri"/>
                         </a:rPr>
-                        <a:t>pending</a:t>
+                        <a:t>|e|₉₉ stable across 5 seeds</a:t>
                       </a:r>
                     </a:p>
                   </a:txBody>
                   <a:tcPr marL="54864" marR="54864" marT="18288" marB="18288">
                     <a:solidFill>
                       <a:srgbClr val="F2F5F8"/>
-                    </a:solidFill>
-                  </a:tcPr>
-                </a:tc>
-              </a:tr>
-              <a:tr h="384048">
-                <a:tc>
-                  <a:txBody>
-                    <a:bodyPr/>
-                    <a:lstStyle/>
-                    <a:p>
-                      <a:r>
-                        <a:rPr sz="1050" b="0">
-                          <a:solidFill>
-                            <a:srgbClr val="1F232B"/>
-                          </a:solidFill>
-                          <a:latin typeface="Calibri"/>
-                        </a:rPr>
-                        <a:t>Convergence / seeds</a:t>
-                      </a:r>
-                    </a:p>
-                  </a:txBody>
-                  <a:tcPr marL="54864" marR="54864" marT="18288" marB="18288">
-                    <a:solidFill>
-                      <a:srgbClr val="FFFFFF"/>
-                    </a:solidFill>
-                  </a:tcPr>
-                </a:tc>
-                <a:tc>
-                  <a:txBody>
-                    <a:bodyPr/>
-                    <a:lstStyle/>
-                    <a:p>
-                      <a:r>
-                        <a:rPr sz="1050" b="0">
-                          <a:solidFill>
-                            <a:srgbClr val="1F232B"/>
-                          </a:solidFill>
-                          <a:latin typeface="Calibri"/>
-                        </a:rPr>
-                        <a:t>|e|₉₉ within ±0.01 % across 5 seeds</a:t>
-                      </a:r>
-                    </a:p>
-                  </a:txBody>
-                  <a:tcPr marL="54864" marR="54864" marT="18288" marB="18288">
-                    <a:solidFill>
-                      <a:srgbClr val="FFFFFF"/>
-                    </a:solidFill>
-                  </a:tcPr>
-                </a:tc>
-                <a:tc>
-                  <a:txBody>
-                    <a:bodyPr/>
-                    <a:lstStyle/>
-                    <a:p>
-                      <a:r>
-                        <a:rPr sz="1050" b="0">
-                          <a:solidFill>
-                            <a:srgbClr val="1F232B"/>
-                          </a:solidFill>
-                          <a:latin typeface="Calibri"/>
-                        </a:rPr>
-                        <a:t>pending</a:t>
-                      </a:r>
-                    </a:p>
-                  </a:txBody>
-                  <a:tcPr marL="54864" marR="54864" marT="18288" marB="18288">
-                    <a:solidFill>
-                      <a:srgbClr val="FFFFFF"/>
                     </a:solidFill>
                   </a:tcPr>
                 </a:tc>
@@ -10845,7 +10871,7 @@
                 </a:solidFill>
                 <a:latin typeface="Calibri"/>
               </a:rPr>
-              <a:t> frame noise is ~1 % and averaged away by the filter; the ±0.5 m/s, ~3 s drift (pitch/ride height, reference lag) sets the bound. A model where that error scales with speed over-predicted the real spread (0.79 vs 0.53 m/s), so the additive model is used. Velocity sensitivity runs are still computing.</a:t>
+              <a:t> frame noise is ~1 % and averaged away by the filter; the ±0.5 m/s, ~3 s drift (pitch/ride height, reference lag) sets the bound. A model where that error scales with speed over-predicted the real spread (0.79 vs 0.53 m/s), so the additive model is used. Frame-noise model (empirical, Gaussian, Student-t, ×3) barely moves the bounds; the drift size does: if half of it is really GPS's own error, the 95 % bound shrinks from ±0.98 to ±0.70 m/s.</a:t>
             </a:r>
           </a:p>
           <a:p>

</xml_diff>